<commit_message>
docs: test count 193 in the README and the deck
</commit_message>
<xml_diff>
--- a/docs/muse-servicedesk-17-cases.pptx
+++ b/docs/muse-servicedesk-17-cases.pptx
@@ -131,7 +131,7 @@
   <p:extLst>
     <p:ext uri="{521415D9-36F7-43E2-AB2F-B90AF26B5E84}">
       <p14:sectionLst xmlns:p14="http://schemas.microsoft.com/office/powerpoint/2010/main">
-        <p14:section name="Overview" id="{a0b29c81-054f-7fe5-1b87-eca7bbfa4fe8}">
+        <p14:section name="Overview" id="{5140d182-0bbd-d3b4-de7f-a07528dd7b26}">
           <p14:sldIdLst>
             <p14:sldId id="256"/>
             <p14:sldId id="257"/>
@@ -139,7 +139,7 @@
             <p14:sldId id="259"/>
           </p14:sldIdLst>
         </p14:section>
-        <p14:section name="Keeps watch on its own" id="{bec91d51-6a63-dd71-7e0c-09a5f19b595b}">
+        <p14:section name="Keeps watch on its own" id="{3650207e-94fe-d5b4-421b-49185fd80636}">
           <p14:sldIdLst>
             <p14:sldId id="260"/>
             <p14:sldId id="261"/>
@@ -149,7 +149,7 @@
             <p14:sldId id="265"/>
           </p14:sldIdLst>
         </p14:section>
-        <p14:section name="Supports whoever writes in" id="{38d80388-850c-63fb-addc-237abbe925de}">
+        <p14:section name="Supports whoever writes in" id="{2803c92d-0f3f-aed8-1427-d2df24584c85}">
           <p14:sldIdLst>
             <p14:sldId id="266"/>
             <p14:sldId id="267"/>
@@ -162,7 +162,7 @@
             <p14:sldId id="274"/>
           </p14:sldIdLst>
         </p14:section>
-        <p14:section name="People, learning, console" id="{d5d27304-a6ce-da63-3a4d-528f36dbeb52}">
+        <p14:section name="People, learning, console" id="{d972c350-828b-ad13-a1ab-ec546860d7ce}">
           <p14:sldIdLst>
             <p14:sldId id="275"/>
             <p14:sldId id="276"/>
@@ -171,7 +171,7 @@
             <p14:sldId id="279"/>
           </p14:sldIdLst>
         </p14:section>
-        <p14:section name="Try it" id="{8465b7a8-0d25-8ee6-40af-e8490cf2b62b}">
+        <p14:section name="Try it" id="{a98d6997-2dc9-f99e-31ce-6a349b4875e4}">
           <p14:sldIdLst>
             <p14:sldId id="280"/>
           </p14:sldIdLst>
@@ -16540,7 +16540,7 @@
                 <a:ea typeface="Arial" pitchFamily="34" charset="-122"/>
                 <a:cs typeface="Arial" pitchFamily="34" charset="-120"/>
               </a:rPr>
-              <a:t>191</a:t>
+              <a:t>193</a:t>
             </a:r>
             <a:endParaRPr lang="en-US" sz="4800" dirty="0"/>
           </a:p>

</xml_diff>